<commit_message>
Week 4 lecture 1 edits.
</commit_message>
<xml_diff>
--- a/lectures/week4/lecture1/slides/week4_lecture1.pptx
+++ b/lectures/week4/lecture1/slides/week4_lecture1.pptx
@@ -84,7 +84,7 @@
     <p:sldId id="341" r:id="rId78"/>
     <p:sldId id="408" r:id="rId79"/>
     <p:sldId id="324" r:id="rId80"/>
-    <p:sldId id="409" r:id="rId81"/>
+    <p:sldId id="410" r:id="rId81"/>
   </p:sldIdLst>
   <p:sldSz cx="12192000" cy="6858000"/>
   <p:notesSz cx="6858000" cy="9144000"/>
@@ -2305,7 +2305,7 @@
                   <a:srgbClr val="66FF99"/>
                 </a:solidFill>
               </a:rPr>
-              <a:t>Lab 3 is released this Thursday 6:00 pm</a:t>
+              <a:t>No labs released this week</a:t>
             </a:r>
             <a:r>
               <a:rPr lang="en-US" sz="1600" dirty="0">
@@ -55072,7 +55072,7 @@
         <p:cNvPr id="1" name="">
           <a:extLst>
             <a:ext uri="{FF2B5EF4-FFF2-40B4-BE49-F238E27FC236}">
-              <a16:creationId xmlns:a16="http://schemas.microsoft.com/office/drawing/2014/main" id="{89543591-A10E-1DD2-14BD-BAC4948F25BD}"/>
+              <a16:creationId xmlns:a16="http://schemas.microsoft.com/office/drawing/2014/main" id="{7BF23A8D-8263-733C-02E6-D3114554A122}"/>
             </a:ext>
           </a:extLst>
         </p:cNvPr>
@@ -55092,7 +55092,7 @@
           <p:cNvPr id="2" name="Title 1">
             <a:extLst>
               <a:ext uri="{FF2B5EF4-FFF2-40B4-BE49-F238E27FC236}">
-                <a16:creationId xmlns:a16="http://schemas.microsoft.com/office/drawing/2014/main" id="{EC8BA022-DBA5-16EC-EFDC-8BE272A0AF6E}"/>
+                <a16:creationId xmlns:a16="http://schemas.microsoft.com/office/drawing/2014/main" id="{ACF5A052-7CBA-5456-F616-5BF6EB8380F8}"/>
               </a:ext>
             </a:extLst>
           </p:cNvPr>
@@ -55130,7 +55130,7 @@
           <p:cNvPr id="3" name="Subtitle 2">
             <a:extLst>
               <a:ext uri="{FF2B5EF4-FFF2-40B4-BE49-F238E27FC236}">
-                <a16:creationId xmlns:a16="http://schemas.microsoft.com/office/drawing/2014/main" id="{BC9715B6-BF76-F833-63C8-5A82966A68D5}"/>
+                <a16:creationId xmlns:a16="http://schemas.microsoft.com/office/drawing/2014/main" id="{7AAD4748-2F31-7E18-FD01-E0DBE11FA658}"/>
               </a:ext>
             </a:extLst>
           </p:cNvPr>
@@ -55226,7 +55226,7 @@
           <p:cNvPr id="4" name="TextBox 3">
             <a:extLst>
               <a:ext uri="{FF2B5EF4-FFF2-40B4-BE49-F238E27FC236}">
-                <a16:creationId xmlns:a16="http://schemas.microsoft.com/office/drawing/2014/main" id="{2B3DD441-B08A-B313-0CA7-8BBFBF27621F}"/>
+                <a16:creationId xmlns:a16="http://schemas.microsoft.com/office/drawing/2014/main" id="{C8F73C39-81A2-1BB3-3E24-348B65B360A9}"/>
               </a:ext>
             </a:extLst>
           </p:cNvPr>
@@ -55302,7 +55302,7 @@
                   <a:srgbClr val="66FF99"/>
                 </a:solidFill>
               </a:rPr>
-              <a:t>Lab 3 is released this Thursday 6:00 pm</a:t>
+              <a:t>No labs released this week</a:t>
             </a:r>
             <a:r>
               <a:rPr lang="en-US" sz="1600" dirty="0">
@@ -55378,7 +55378,7 @@
     </p:spTree>
     <p:extLst>
       <p:ext uri="{BB962C8B-B14F-4D97-AF65-F5344CB8AC3E}">
-        <p14:creationId xmlns:p14="http://schemas.microsoft.com/office/powerpoint/2010/main" val="3750289960"/>
+        <p14:creationId xmlns:p14="http://schemas.microsoft.com/office/powerpoint/2010/main" val="2716359307"/>
       </p:ext>
     </p:extLst>
   </p:cSld>

</xml_diff>